<commit_message>
Update documentation and code examples across multiple sections
- Revised the RAG retrieval documentation to clarify multimodal ingestion and added a worked example for BM25 from scratch.
- Updated links and references in the agentic foundations section to reflect changes in the evaluation and harness architecture documentation.
- Corrected chapter references in the RL section to align with the latest version of *AI Agents in Depth*.
- Adjusted lab references in the real-time multimodal agents section to point to the correct chapter.
- Enhanced the resources section to reflect the latest chapters and their corresponding links.
</commit_message>
<xml_diff>
--- a/ai-engineering/03-harness-engineering/slides/harness-engineering.pptx
+++ b/ai-engineering/03-harness-engineering/slides/harness-engineering.pptx
@@ -18504,7 +18504,7 @@
       </p:sp>
       <p:pic>
         <p:nvPicPr>
-          <p:cNvPr id="11" name="Picture 10" descr="li-ai-agents-in-depth-fig4-2-7197394881132739380.png"/>
+          <p:cNvPr id="11" name="Picture 10" descr="li-ai-agents-in-depth-fig4-2-927427184457461408.png"/>
           <p:cNvPicPr>
             <a:picLocks noChangeAspect="1"/>
           </p:cNvPicPr>
@@ -21009,7 +21009,7 @@
       </p:sp>
       <p:pic>
         <p:nvPicPr>
-          <p:cNvPr id="11" name="Picture 10" descr="li-ai-agents-in-depth-fig5-4-4989701770481481543.png"/>
+          <p:cNvPr id="11" name="Picture 10" descr="li-ai-agents-in-depth-fig5-4-3578337933789889102.png"/>
           <p:cNvPicPr>
             <a:picLocks noChangeAspect="1"/>
           </p:cNvPicPr>
@@ -55012,7 +55012,7 @@
                 </a:solidFill>
                 <a:latin typeface="Helvetica Neue"/>
               </a:rPr>
-              <a:t>Entry file </a:t>
+              <a:t>Root file: start near </a:t>
             </a:r>
             <a:r>
               <a:rPr sz="1800" i="0" b="1">
@@ -55021,7 +55021,7 @@
                 </a:solidFill>
                 <a:latin typeface="Helvetica Neue"/>
               </a:rPr>
-              <a:t>50–200 lines</a:t>
+              <a:t>60 lines</a:t>
             </a:r>
             <a:r>
               <a:rPr sz="1800" i="0" b="0">
@@ -58140,7 +58140,7 @@
         <p:spPr>
           <a:xfrm>
             <a:off x="822960" y="3118104"/>
-            <a:ext cx="5944038" cy="762000"/>
+            <a:ext cx="5944038" cy="1097280"/>
           </a:xfrm>
           <a:prstGeom prst="rect">
             <a:avLst/>
@@ -58165,7 +58165,7 @@
                 </a:solidFill>
                 <a:latin typeface="Helvetica Neue"/>
               </a:rPr>
-              <a:t>Do the labs:</a:t>
+              <a:t>Read:</a:t>
             </a:r>
             <a:r>
               <a:rPr sz="2000" i="0" b="0">
@@ -58174,7 +58174,7 @@
                 </a:solidFill>
                 <a:latin typeface="Helvetica Neue"/>
               </a:rPr>
-              <a:t> practice/exercises.md, six labs on a repo of your own</a:t>
+              <a:t> Anthropic on long-running harnesses; OpenAI on harness engineering; Li, AI Agents in Depth</a:t>
             </a:r>
           </a:p>
         </p:txBody>
@@ -58182,98 +58182,6 @@
       <p:sp>
         <p:nvSpPr>
           <p:cNvPr id="16" name="Rectangle 15"/>
-          <p:cNvSpPr/>
-          <p:nvPr/>
-        </p:nvSpPr>
-        <p:spPr>
-          <a:xfrm>
-            <a:off x="502920" y="4037584"/>
-            <a:ext cx="106680" cy="106680"/>
-          </a:xfrm>
-          <a:prstGeom prst="rect">
-            <a:avLst/>
-          </a:prstGeom>
-          <a:solidFill>
-            <a:srgbClr val="166534"/>
-          </a:solidFill>
-          <a:ln>
-            <a:noFill/>
-          </a:ln>
-          <a:effectLst/>
-        </p:spPr>
-        <p:style>
-          <a:lnRef idx="1">
-            <a:schemeClr val="accent1"/>
-          </a:lnRef>
-          <a:fillRef idx="3">
-            <a:schemeClr val="accent1"/>
-          </a:fillRef>
-          <a:effectRef idx="2">
-            <a:schemeClr val="accent1"/>
-          </a:effectRef>
-          <a:fontRef idx="minor">
-            <a:schemeClr val="lt1"/>
-          </a:fontRef>
-        </p:style>
-        <p:txBody>
-          <a:bodyPr rtlCol="0" anchor="ctr"/>
-          <a:lstStyle/>
-          <a:p>
-            <a:pPr algn="ctr"/>
-          </a:p>
-        </p:txBody>
-      </p:sp>
-      <p:sp>
-        <p:nvSpPr>
-          <p:cNvPr id="17" name="TextBox 16"/>
-          <p:cNvSpPr txBox="1"/>
-          <p:nvPr/>
-        </p:nvSpPr>
-        <p:spPr>
-          <a:xfrm>
-            <a:off x="822960" y="3941064"/>
-            <a:ext cx="5944038" cy="1097280"/>
-          </a:xfrm>
-          <a:prstGeom prst="rect">
-            <a:avLst/>
-          </a:prstGeom>
-          <a:noFill/>
-        </p:spPr>
-        <p:txBody>
-          <a:bodyPr wrap="square" lIns="0" rIns="0" tIns="0" bIns="0" anchor="t">
-            <a:noAutofit/>
-          </a:bodyPr>
-          <a:lstStyle/>
-          <a:p>
-            <a:pPr algn="l">
-              <a:lnSpc>
-                <a:spcPct val="110000"/>
-              </a:lnSpc>
-            </a:pPr>
-            <a:r>
-              <a:rPr sz="2000" i="0" b="1">
-                <a:solidFill>
-                  <a:srgbClr val="1E293B"/>
-                </a:solidFill>
-                <a:latin typeface="Helvetica Neue"/>
-              </a:rPr>
-              <a:t>Read:</a:t>
-            </a:r>
-            <a:r>
-              <a:rPr sz="2000" i="0" b="0">
-                <a:solidFill>
-                  <a:srgbClr val="1E293B"/>
-                </a:solidFill>
-                <a:latin typeface="Helvetica Neue"/>
-              </a:rPr>
-              <a:t> Anthropic on long-running harnesses; OpenAI on harness engineering; Li, AI Agents in Depth</a:t>
-            </a:r>
-          </a:p>
-        </p:txBody>
-      </p:sp>
-      <p:sp>
-        <p:nvSpPr>
-          <p:cNvPr id="18" name="Rectangle 17"/>
           <p:cNvSpPr/>
           <p:nvPr/>
         </p:nvSpPr>
@@ -58319,7 +58227,7 @@
       </p:sp>
       <p:sp>
         <p:nvSpPr>
-          <p:cNvPr id="19" name="Rectangle 18"/>
+          <p:cNvPr id="17" name="Rectangle 16"/>
           <p:cNvSpPr/>
           <p:nvPr/>
         </p:nvSpPr>
@@ -58363,7 +58271,7 @@
       </p:sp>
       <p:sp>
         <p:nvSpPr>
-          <p:cNvPr id="20" name="TextBox 19"/>
+          <p:cNvPr id="18" name="TextBox 17"/>
           <p:cNvSpPr txBox="1"/>
           <p:nvPr/>
         </p:nvSpPr>
@@ -58402,7 +58310,7 @@
       </p:sp>
       <p:sp>
         <p:nvSpPr>
-          <p:cNvPr id="21" name="TextBox 20"/>
+          <p:cNvPr id="19" name="TextBox 18"/>
           <p:cNvSpPr txBox="1"/>
           <p:nvPr/>
         </p:nvSpPr>

</xml_diff>